<commit_message>
Bob-a-thon Hackathon V1.1: Complete IBM ICA Integration with MCP Server
- Added comprehensive hackathon documentation (HACKATHON_JOURNEY.md, .docx)
- Created detailed Context Studio schema (context_schema.yaml - 812 lines)
- Added bulk import file with 11 API tools (refund-api-bulk-import-v2.json - 465 lines)
- Implemented MCP server with JSON-RPC 2.0 protocol
- Added 30+ integration guides and troubleshooting docs
- Created PowerPoint V1.1 with detailed schema information
- Added audio transcript and generation scripts
- Integrated with IBM ICA Agent Orchestration (LangGraph + ReAct)
- Successfully linked 7 MCP tools to ICA agent
- All demo prompts tested and working (100% success rate)
- Added Watsonx integration files
- Enhanced backend with MCP endpoints
- Complete end-to-end integration working
</commit_message>
<xml_diff>
--- a/Refund_Intelligence_Platform_Demo.pptx
+++ b/Refund_Intelligence_Platform_Demo.pptx
@@ -318,7 +318,7 @@
           <a:p>
             <a:fld id="{5BCAD085-E8A6-8845-BD4E-CB4CCA059FC4}" type="datetimeFigureOut">
               <a:rPr lang="en-US" smtClean="0"/>
-              <a:t>5/16/2026</a:t>
+              <a:t>5/18/2026</a:t>
             </a:fld>
             <a:endParaRPr lang="en-US"/>
           </a:p>
@@ -486,7 +486,7 @@
           <a:p>
             <a:fld id="{5BCAD085-E8A6-8845-BD4E-CB4CCA059FC4}" type="datetimeFigureOut">
               <a:rPr lang="en-US" smtClean="0"/>
-              <a:t>5/16/2026</a:t>
+              <a:t>5/18/2026</a:t>
             </a:fld>
             <a:endParaRPr lang="en-US"/>
           </a:p>
@@ -664,7 +664,7 @@
           <a:p>
             <a:fld id="{5BCAD085-E8A6-8845-BD4E-CB4CCA059FC4}" type="datetimeFigureOut">
               <a:rPr lang="en-US" smtClean="0"/>
-              <a:t>5/16/2026</a:t>
+              <a:t>5/18/2026</a:t>
             </a:fld>
             <a:endParaRPr lang="en-US"/>
           </a:p>
@@ -832,7 +832,7 @@
           <a:p>
             <a:fld id="{5BCAD085-E8A6-8845-BD4E-CB4CCA059FC4}" type="datetimeFigureOut">
               <a:rPr lang="en-US" smtClean="0"/>
-              <a:t>5/16/2026</a:t>
+              <a:t>5/18/2026</a:t>
             </a:fld>
             <a:endParaRPr lang="en-US"/>
           </a:p>
@@ -1077,7 +1077,7 @@
           <a:p>
             <a:fld id="{5BCAD085-E8A6-8845-BD4E-CB4CCA059FC4}" type="datetimeFigureOut">
               <a:rPr lang="en-US" smtClean="0"/>
-              <a:t>5/16/2026</a:t>
+              <a:t>5/18/2026</a:t>
             </a:fld>
             <a:endParaRPr lang="en-US"/>
           </a:p>
@@ -1362,7 +1362,7 @@
           <a:p>
             <a:fld id="{5BCAD085-E8A6-8845-BD4E-CB4CCA059FC4}" type="datetimeFigureOut">
               <a:rPr lang="en-US" smtClean="0"/>
-              <a:t>5/16/2026</a:t>
+              <a:t>5/18/2026</a:t>
             </a:fld>
             <a:endParaRPr lang="en-US"/>
           </a:p>
@@ -1781,7 +1781,7 @@
           <a:p>
             <a:fld id="{5BCAD085-E8A6-8845-BD4E-CB4CCA059FC4}" type="datetimeFigureOut">
               <a:rPr lang="en-US" smtClean="0"/>
-              <a:t>5/16/2026</a:t>
+              <a:t>5/18/2026</a:t>
             </a:fld>
             <a:endParaRPr lang="en-US"/>
           </a:p>
@@ -1898,7 +1898,7 @@
           <a:p>
             <a:fld id="{5BCAD085-E8A6-8845-BD4E-CB4CCA059FC4}" type="datetimeFigureOut">
               <a:rPr lang="en-US" smtClean="0"/>
-              <a:t>5/16/2026</a:t>
+              <a:t>5/18/2026</a:t>
             </a:fld>
             <a:endParaRPr lang="en-US"/>
           </a:p>
@@ -1993,7 +1993,7 @@
           <a:p>
             <a:fld id="{5BCAD085-E8A6-8845-BD4E-CB4CCA059FC4}" type="datetimeFigureOut">
               <a:rPr lang="en-US" smtClean="0"/>
-              <a:t>5/16/2026</a:t>
+              <a:t>5/18/2026</a:t>
             </a:fld>
             <a:endParaRPr lang="en-US"/>
           </a:p>
@@ -2268,7 +2268,7 @@
           <a:p>
             <a:fld id="{5BCAD085-E8A6-8845-BD4E-CB4CCA059FC4}" type="datetimeFigureOut">
               <a:rPr lang="en-US" smtClean="0"/>
-              <a:t>5/16/2026</a:t>
+              <a:t>5/18/2026</a:t>
             </a:fld>
             <a:endParaRPr lang="en-US"/>
           </a:p>
@@ -2520,7 +2520,7 @@
           <a:p>
             <a:fld id="{5BCAD085-E8A6-8845-BD4E-CB4CCA059FC4}" type="datetimeFigureOut">
               <a:rPr lang="en-US" smtClean="0"/>
-              <a:t>5/16/2026</a:t>
+              <a:t>5/18/2026</a:t>
             </a:fld>
             <a:endParaRPr lang="en-US"/>
           </a:p>
@@ -2731,7 +2731,7 @@
           <a:p>
             <a:fld id="{5BCAD085-E8A6-8845-BD4E-CB4CCA059FC4}" type="datetimeFigureOut">
               <a:rPr lang="en-US" smtClean="0"/>
-              <a:t>5/16/2026</a:t>
+              <a:t>5/18/2026</a:t>
             </a:fld>
             <a:endParaRPr lang="en-US"/>
           </a:p>

</xml_diff>